<commit_message>
Deck: contractions, no fragment negations
Co-Authored-By: Claude Fable 5.1 <noreply@anthropic.com>
</commit_message>
<xml_diff>
--- a/submission/Curb-Cut.pptx
+++ b/submission/Curb-Cut.pptx
@@ -1502,7 +1502,7 @@
           <a:p>
             <a:r>
               <a:rPr lang="en-US" dirty="0"/>
-              <a:t>Say the first line, then pause. Let people actually remember. Do not rush to the second line. Nobody needs a citation for this one because everybody has lived it.</a:t>
+              <a:t>Say the first line, then pause. Let people actually remember. Don't rush to the second line. Nobody needs a citation for this one because everybody has lived it.</a:t>
             </a:r>
             <a:endParaRPr lang="en-US" dirty="0"/>
           </a:p>
@@ -2910,7 +2910,7 @@
           <a:p>
             <a:r>
               <a:rPr lang="en-US" dirty="0"/>
-              <a:t>This is the moral argument. Do not rush it and do not soften it.</a:t>
+              <a:t>This is the moral argument. Don't rush it and don't soften it.</a:t>
             </a:r>
             <a:endParaRPr lang="en-US" dirty="0"/>
           </a:p>
@@ -3174,7 +3174,7 @@
           <a:p>
             <a:r>
               <a:rPr lang="en-US" dirty="0"/>
-              <a:t>This is the sentence the standing preference exists for. Call back to it later. If asked about the date: the gap it describes was measured again by Statistics Canada in 2022 and by the US Bureau of Labor Statistics in 2025, and it has not closed.</a:t>
+              <a:t>This is the sentence the standing preference exists for. Call back to it later. If asked about the date: the gap it describes was measured again by Statistics Canada in 2022 and by the US Bureau of Labor Statistics in 2025, and it hasn't closed.</a:t>
             </a:r>
             <a:endParaRPr lang="en-US" dirty="0"/>
           </a:p>
@@ -6681,7 +6681,7 @@
                 <a:ea typeface="Cambria" pitchFamily="34" charset="-122"/>
                 <a:cs typeface="Cambria" pitchFamily="34" charset="-120"/>
               </a:rPr>
-              <a:t>The gap is not a spending gap. It is a process gap, which is cheaper to close and harder to sell, because no budget line says "the asking was too hard".</a:t>
+              <a:t>The gap isn't a spending gap. It is a process gap, which is cheaper to close and harder to sell, because no budget line says "the asking was too hard".</a:t>
             </a:r>
             <a:endParaRPr lang="en-US" sz="1600" dirty="0"/>
           </a:p>
@@ -8250,7 +8250,7 @@
                 <a:ea typeface="Calibri" pitchFamily="34" charset="-122"/>
                 <a:cs typeface="Calibri" pitchFamily="34" charset="-120"/>
               </a:rPr>
-              <a:t>Six classes write to it. None can write a body, because there is no field for one. Five reports and one dashboard sit on top of it for the person on duty: who is waiting, what did not arrive, who needs an interpreter.</a:t>
+              <a:t>Six classes write to it. None can write a body, because there's no field for one. Five reports and one dashboard sit on top of it for the person on duty: who is waiting, what didn't arrive, who needs an interpreter.</a:t>
             </a:r>
             <a:endParaRPr lang="en-US" sz="1350" dirty="0"/>
           </a:p>
@@ -9408,7 +9408,7 @@
                 <a:ea typeface="Cambria" pitchFamily="34" charset="-122"/>
                 <a:cs typeface="Cambria" pitchFamily="34" charset="-120"/>
               </a:rPr>
-              <a:t>Steps one to four contain no inference at all. The cheapest system is the one that does not ask a model a question it already knows the answer to.</a:t>
+              <a:t>Steps one to four contain no inference at all. The cheapest system is the one that doesn't ask a model a question it already knows the answer to.</a:t>
             </a:r>
             <a:endParaRPr lang="en-US" sz="1600" dirty="0"/>
           </a:p>
@@ -11291,7 +11291,7 @@
                 <a:ea typeface="Cambria" pitchFamily="34" charset="-122"/>
                 <a:cs typeface="Cambria" pitchFamily="34" charset="-120"/>
               </a:rPr>
-              <a:t>Email and Slack deliberately will not send. Agreeing in writing days later is not the same as choosing in the moment.</a:t>
+              <a:t>Email and Slack deliberately won't send. Agreeing in writing days later isn't the same as choosing in the moment.</a:t>
             </a:r>
             <a:endParaRPr lang="en-US" sz="1600" dirty="0"/>
           </a:p>
@@ -12268,7 +12268,7 @@
                 <a:ea typeface="Cambria" pitchFamily="34" charset="-122"/>
                 <a:cs typeface="Cambria" pitchFamily="34" charset="-120"/>
               </a:rPr>
-              <a:t>There is no field for a diagnosis.</a:t>
+              <a:t>There's no field for a diagnosis.</a:t>
             </a:r>
             <a:endParaRPr lang="en-US" sz="3300" dirty="0"/>
           </a:p>
@@ -12910,7 +12910,7 @@
                 <a:ea typeface="Calibri" pitchFamily="34" charset="-122"/>
                 <a:cs typeface="Calibri" pitchFamily="34" charset="-120"/>
               </a:rPr>
-              <a:t>You worked out what it would take to ask. Who you would have to tell. How it would sound. And you decided it was not worth the conversation.</a:t>
+              <a:t>You worked out what it would take to ask. Who you would have to tell. How it would sound. And you decided it wasn't worth the conversation.</a:t>
             </a:r>
             <a:endParaRPr lang="en-US" sz="2100" dirty="0"/>
           </a:p>
@@ -13176,7 +13176,7 @@
                 <a:ea typeface="Calibri" pitchFamily="34" charset="-122"/>
                 <a:cs typeface="Calibri" pitchFamily="34" charset="-120"/>
               </a:rPr>
-              <a:t>There is no field for a diagnosis, condition, disability type, medical note, severity or prognosis anywhere in this system. Nobody holds that, including the person who built it, and the person you are helping was never asked.</a:t>
+              <a:t>There's no field for a diagnosis, condition, disability type, medical note, severity or prognosis anywhere in this system. Nobody holds that, including the person who built it, and the person you are helping was never asked.</a:t>
             </a:r>
             <a:endParaRPr lang="en-US" sz="1550" dirty="0"/>
           </a:p>
@@ -13616,7 +13616,7 @@
                 <a:ea typeface="Calibri" pitchFamily="34" charset="-122"/>
                 <a:cs typeface="Calibri" pitchFamily="34" charset="-120"/>
               </a:rPr>
-              <a:t>Six control words were printed in our own copy and routed nowhere. The word that withdraws a disclosure returned "I do not have good information on that", and the sharing stayed on.</a:t>
+              <a:t>Six control words were printed in our own copy and routed nowhere. The word that withdraws a disclosure returned "I don't have good information on that", and the sharing stayed on.</a:t>
             </a:r>
             <a:endParaRPr lang="en-US" sz="1200" dirty="0"/>
           </a:p>
@@ -13719,7 +13719,7 @@
                 <a:ea typeface="Calibri" pitchFamily="34" charset="-122"/>
                 <a:cs typeface="Calibri" pitchFamily="34" charset="-120"/>
               </a:rPr>
-              <a:t>It said a volunteered condition "is not written to any record". It was stored word for word. Now stripped before the insert, with the claim rewritten to state its limit.</a:t>
+              <a:t>It said a volunteered condition "isn't written to any record". It was stored word for word. Now stripped before the insert, with the claim rewritten to state its limit.</a:t>
             </a:r>
             <a:endParaRPr lang="en-US" sz="1200" dirty="0"/>
           </a:p>
@@ -13971,7 +13971,7 @@
                 <a:ea typeface="Cambria" pitchFamily="34" charset="-122"/>
                 <a:cs typeface="Cambria" pitchFamily="34" charset="-120"/>
               </a:rPr>
-              <a:t>The tool could not decide the thing that mattered.</a:t>
+              <a:t>The tool couldn't decide the thing that mattered.</a:t>
             </a:r>
             <a:endParaRPr lang="en-US" sz="3300" dirty="0"/>
           </a:p>
@@ -14181,7 +14181,7 @@
                 <a:ea typeface="Calibri" pitchFamily="34" charset="-122"/>
                 <a:cs typeface="Calibri" pitchFamily="34" charset="-120"/>
               </a:rPr>
-              <a:t>On the signed video, WCAG 1.2.2 came back incomplete, not pass. Inside a test runner axe cannot inspect media. So it could not settle it. A person using a screen reader would have settled it immediately.</a:t>
+              <a:t>On the signed video, WCAG 1.2.2 came back incomplete, not pass. Inside a test runner axe can't inspect media. So it couldn't settle it. A person using a screen reader would have settled it immediately.</a:t>
             </a:r>
             <a:endParaRPr lang="en-US" sz="1200" dirty="0"/>
           </a:p>
@@ -14220,7 +14220,7 @@
                 <a:ea typeface="Calibri" pitchFamily="34" charset="-122"/>
                 <a:cs typeface="Calibri" pitchFamily="34" charset="-120"/>
               </a:rPr>
-              <a:t>The obvious remedy was the forbidden one. That video is usually a Deaf person signing, and a machine caption would put words in somebody’s mouth about their own body, then file them. So the video now says so itself, to the person who cannot watch it:</a:t>
+              <a:t>The obvious remedy was the forbidden one. That video is usually a Deaf person signing, and a machine caption would put words in somebody’s mouth about their own body, then file them. So the video now says so itself, to the person who can't watch it:</a:t>
             </a:r>
             <a:endParaRPr lang="en-US" sz="1350" dirty="0"/>
           </a:p>
@@ -14323,7 +14323,7 @@
                 <a:ea typeface="Cambria" pitchFamily="34" charset="-122"/>
                 <a:cs typeface="Cambria" pitchFamily="34" charset="-120"/>
               </a:rPr>
-              <a:t>An incomplete is not a pass. Reporting it as one would have been the easiest lie in the submission.</a:t>
+              <a:t>An incomplete isn't a pass. Reporting it as one would have been the easiest lie in the submission.</a:t>
             </a:r>
             <a:endParaRPr lang="en-US" sz="1600" dirty="0"/>
           </a:p>
@@ -14433,7 +14433,7 @@
                 <a:ea typeface="Cambria" pitchFamily="34" charset="-122"/>
                 <a:cs typeface="Cambria" pitchFamily="34" charset="-120"/>
               </a:rPr>
-              <a:t>Our own repository could not rebuild us.</a:t>
+              <a:t>Our own repository couldn't rebuild us.</a:t>
             </a:r>
             <a:endParaRPr lang="en-US" sz="3300" dirty="0"/>
           </a:p>
@@ -14975,7 +14975,7 @@
                 <a:ea typeface="Calibri" pitchFamily="34" charset="-122"/>
                 <a:cs typeface="Calibri" pitchFamily="34" charset="-120"/>
               </a:rPr>
-              <a:t>It also produced a finding we withdrew. A check demanded every row state a cost; nine do not. But the code was already right: it says it has no figure and refuses to estimate one. We corrected the check, not the code, and left it in the file with a note that it was wrong the first time.</a:t>
+              <a:t>It also produced a finding we withdrew. A check demanded every row state a cost; nine don't. But the code was already right: it says it has no figure and refuses to estimate one. We corrected the check, not the code, and left it in the file with a note that it was wrong the first time.</a:t>
             </a:r>
             <a:endParaRPr lang="en-US" sz="1250" dirty="0"/>
           </a:p>
@@ -15226,7 +15226,7 @@
                 <a:ea typeface="Calibri" pitchFamily="34" charset="-122"/>
                 <a:cs typeface="Calibri" pitchFamily="34" charset="-120"/>
               </a:rPr>
-              <a:t>the agent does not reliably say out loud that it discarded a volunteered condition</a:t>
+              <a:t>the agent doesn't reliably say out loud that it discarded a volunteered condition</a:t>
             </a:r>
             <a:endParaRPr lang="en-US" sz="1400" dirty="0"/>
           </a:p>
@@ -15450,7 +15450,7 @@
                 <a:ea typeface="Courier New" pitchFamily="34" charset="-122"/>
                 <a:cs typeface="Courier New" pitchFamily="34" charset="-120"/>
               </a:rPr>
-              <a:t>124 Apex   |   494 invariants   |   333 accessibility   |   131 Sa11y   |   28 contrast   |   16 reading level   |   all passing, every build</a:t>
+              <a:t>137 Apex   |   508 invariants   |   333 accessibility   |   131 Sa11y   |   28 contrast   |   16 reading level   |   all passing, every build</a:t>
             </a:r>
             <a:endParaRPr lang="en-US" sz="1200" dirty="0"/>
           </a:p>
@@ -15638,7 +15638,7 @@
                 <a:ea typeface="Calibri" pitchFamily="34" charset="-122"/>
                 <a:cs typeface="Calibri" pitchFamily="34" charset="-120"/>
               </a:rPr>
-              <a:t>Every accessibility claim is machine or browser verified, which is not the same as a person using it. One session with somebody who uses one daily is worth more than the next five features.</a:t>
+              <a:t>Every accessibility claim is machine or browser verified, which isn't the same as a person using it. One session with somebody who uses one daily is worth more than the next five features.</a:t>
             </a:r>
             <a:endParaRPr lang="en-US" sz="1150" dirty="0"/>
           </a:p>
@@ -15716,7 +15716,7 @@
                 <a:ea typeface="Calibri" pitchFamily="34" charset="-122"/>
                 <a:cs typeface="Calibri" pitchFamily="34" charset="-120"/>
               </a:rPr>
-              <a:t>It rewrites what an action returns rather than relaying it. Three separate fixes did not move it.</a:t>
+              <a:t>It rewrites what an action returns rather than relaying it. Three separate fixes didn't move it.</a:t>
             </a:r>
             <a:endParaRPr lang="en-US" sz="1150" dirty="0"/>
           </a:p>
@@ -15755,7 +15755,7 @@
                 <a:ea typeface="Cambria" pitchFamily="34" charset="-122"/>
                 <a:cs typeface="Cambria" pitchFamily="34" charset="-120"/>
               </a:rPr>
-              <a:t>Text messaging is not carrier registered.</a:t>
+              <a:t>Text messaging isn't carrier registered.</a:t>
             </a:r>
             <a:endParaRPr lang="en-US" sz="1350" dirty="0"/>
           </a:p>
@@ -15872,7 +15872,7 @@
                 <a:ea typeface="Calibri" pitchFamily="34" charset="-122"/>
                 <a:cs typeface="Calibri" pitchFamily="34" charset="-120"/>
               </a:rPr>
-              <a:t>The Apex behind it is live and verified. The handshake is not.</a:t>
+              <a:t>The Apex behind it is live and verified. The handshake isn't.</a:t>
             </a:r>
             <a:endParaRPr lang="en-US" sz="1150" dirty="0"/>
           </a:p>
@@ -16060,7 +16060,7 @@
                 <a:ea typeface="Calibri" pitchFamily="34" charset="-122"/>
                 <a:cs typeface="Calibri" pitchFamily="34" charset="-120"/>
               </a:rPr>
-              <a:t>Why this has not happened, and why that is over.</a:t>
+              <a:t>Why this hasn't happened, and why that is over.</a:t>
             </a:r>
             <a:endParaRPr lang="en-US" sz="1600" dirty="0"/>
           </a:p>
@@ -16170,7 +16170,7 @@
                 <a:ea typeface="Cambria" pitchFamily="34" charset="-122"/>
                 <a:cs typeface="Cambria" pitchFamily="34" charset="-120"/>
               </a:rPr>
-              <a:t>Why good employers have not done this.</a:t>
+              <a:t>Why good employers haven't done this.</a:t>
             </a:r>
             <a:endParaRPr lang="en-US" sz="3300" dirty="0"/>
           </a:p>
@@ -16273,7 +16273,7 @@
                 <a:ea typeface="Calibri" pitchFamily="34" charset="-122"/>
                 <a:cs typeface="Calibri" pitchFamily="34" charset="-120"/>
               </a:rPr>
-              <a:t>The cost is real and has never been priced, so it has never been funded. You cannot get money for a problem with no line item.</a:t>
+              <a:t>The cost is real and has never been priced, so it has never been funded. You can't get money for a problem with no line item.</a:t>
             </a:r>
             <a:endParaRPr lang="en-US" sz="1150" dirty="0"/>
           </a:p>
@@ -16479,7 +16479,7 @@
                 <a:ea typeface="Calibri" pitchFamily="34" charset="-122"/>
                 <a:cs typeface="Calibri" pitchFamily="34" charset="-120"/>
               </a:rPr>
-              <a:t>Handling a disclosure badly carries legal risk, so doing nothing feels safest. It is not safer. It is only quieter.</a:t>
+              <a:t>Handling a disclosure badly carries legal risk, so doing nothing feels safest. It isn't safer. It is only quieter.</a:t>
             </a:r>
             <a:endParaRPr lang="en-US" sz="1150" dirty="0"/>
           </a:p>
@@ -17259,7 +17259,7 @@
                 <a:ea typeface="Calibri" pitchFamily="34" charset="-122"/>
                 <a:cs typeface="Calibri" pitchFamily="34" charset="-120"/>
               </a:rPr>
-              <a:t>We are not asking for a case study or a logo. Those five things are what actually makes an accommodation arrive, and an organisation unwilling to do them would not have got value from the software either.</a:t>
+              <a:t>We aren't asking for a case study or a logo. Those five things are what actually makes an accommodation arrive, and an organisation unwilling to do them wouldn't have got value from the software either.</a:t>
             </a:r>
             <a:endParaRPr lang="en-US" sz="1350" dirty="0"/>
           </a:p>
@@ -17470,7 +17470,7 @@
                 <a:ea typeface="Calibri" pitchFamily="34" charset="-122"/>
                 <a:cs typeface="Calibri" pitchFamily="34" charset="-120"/>
               </a:rPr>
-              <a:t>For roughly three in ten people at work, that calculation is not occasional. It is a standing condition of the job, and the price of getting it wrong is not an awkward moment. It is being seen as difficult, or fragile, or not worth staffing.</a:t>
+              <a:t>For roughly three in ten people at work, that calculation isn't occasional. It is a standing condition of the job, and the price of getting it wrong isn't an awkward moment. It is being seen as difficult, or fragile, or not worth staffing.</a:t>
             </a:r>
             <a:endParaRPr lang="en-US" sz="1600" dirty="0"/>
           </a:p>
@@ -17721,7 +17721,7 @@
                 <a:ea typeface="Cambria" pitchFamily="34" charset="-122"/>
                 <a:cs typeface="Cambria" pitchFamily="34" charset="-120"/>
               </a:rPr>
-              <a:t>It does not want to understand her. It wants a diagnosis, in writing, for somebody who will still be her manager on Monday.</a:t>
+              <a:t>It doesn't want to understand her. It wants a diagnosis, in writing, for somebody who will still be her manager on Monday.</a:t>
             </a:r>
             <a:endParaRPr lang="en-US" sz="1600" dirty="0"/>
           </a:p>
@@ -18850,7 +18850,7 @@
                 <a:ea typeface="Cambria" pitchFamily="34" charset="-122"/>
                 <a:cs typeface="Cambria" pitchFamily="34" charset="-120"/>
               </a:rPr>
-              <a:t>Do not take any of it on trust.</a:t>
+              <a:t>Don't take any of it on trust.</a:t>
             </a:r>
             <a:endParaRPr lang="en-US" sz="3300" dirty="0"/>
           </a:p>
@@ -18889,7 +18889,7 @@
                 <a:ea typeface="Courier New" pitchFamily="34" charset="-122"/>
                 <a:cs typeface="Courier New" pitchFamily="34" charset="-120"/>
               </a:rPr>
-              <a:t>494</a:t>
+              <a:t>508</a:t>
             </a:r>
             <a:endParaRPr lang="en-US" sz="1600" dirty="0"/>
           </a:p>
@@ -20149,7 +20149,7 @@
                 <a:ea typeface="Courier New" pitchFamily="34" charset="-122"/>
                 <a:cs typeface="Courier New" pitchFamily="34" charset="-120"/>
               </a:rPr>
-              <a:t>python3 tests/invariants.py          494 checks</a:t>
+              <a:t>python3 tests/invariants.py          508 checks</a:t>
             </a:r>
             <a:endParaRPr lang="en-US" sz="1050" dirty="0"/>
           </a:p>
@@ -20166,7 +20166,7 @@
                 <a:ea typeface="Courier New" pitchFamily="34" charset="-122"/>
                 <a:cs typeface="Courier New" pitchFamily="34" charset="-120"/>
               </a:rPr>
-              <a:t>sf apex run test -l RunLocalTests     124 tests</a:t>
+              <a:t>sf apex run test -l RunLocalTests     137 tests</a:t>
             </a:r>
             <a:endParaRPr lang="en-US" sz="1050" dirty="0"/>
           </a:p>
@@ -20332,7 +20332,7 @@
                 <a:ea typeface="Cambria" pitchFamily="34" charset="-122"/>
                 <a:cs typeface="Cambria" pitchFamily="34" charset="-120"/>
               </a:rPr>
-              <a:t>One roadblock is not one bad day.</a:t>
+              <a:t>One roadblock isn't one bad day.</a:t>
             </a:r>
             <a:endParaRPr lang="en-US" sz="3300" dirty="0"/>
           </a:p>
@@ -20608,7 +20608,7 @@
                 <a:ea typeface="Cambria" pitchFamily="34" charset="-122"/>
                 <a:cs typeface="Cambria" pitchFamily="34" charset="-120"/>
               </a:rPr>
-              <a:t>It is almost always man-made</a:t>
+              <a:t>It's almost always man-made</a:t>
             </a:r>
             <a:endParaRPr lang="en-US" sz="1500" dirty="0"/>
           </a:p>
@@ -20647,7 +20647,7 @@
                 <a:ea typeface="Calibri" pitchFamily="34" charset="-122"/>
                 <a:cs typeface="Calibri" pitchFamily="34" charset="-120"/>
               </a:rPr>
-              <a:t>Not the condition. The form, the login, the policy nobody can find, the manager who needs proof.</a:t>
+              <a:t>Not the condition itself, but the form, the login, the policy nobody can find, and the manager who needs proof.</a:t>
             </a:r>
             <a:endParaRPr lang="en-US" sz="1200" dirty="0"/>
           </a:p>
@@ -20791,7 +20791,7 @@
                 <a:ea typeface="Cambria" pitchFamily="34" charset="-122"/>
                 <a:cs typeface="Cambria" pitchFamily="34" charset="-120"/>
               </a:rPr>
-              <a:t>We say everyone is equal. In a market, everyone is a transaction. It should not take a dataset to argue that a person is worth an hour of flexibility. Here is the dataset anyway.</a:t>
+              <a:t>We say everyone is equal. In a market, everyone is a transaction. It shouldn't take a dataset to argue that a person is worth an hour of flexibility. Here is the dataset anyway.</a:t>
             </a:r>
             <a:endParaRPr lang="en-US" sz="1600" dirty="0"/>
           </a:p>
@@ -21252,7 +21252,7 @@
                 <a:ea typeface="Calibri" pitchFamily="34" charset="-122"/>
                 <a:cs typeface="Calibri" pitchFamily="34" charset="-120"/>
               </a:rPr>
-              <a:t>Reference architecture, the channel layer, the grounding path, and the three rules the system will not break</a:t>
+              <a:t>Reference architecture, the channel layer, the grounding path, and the three rules the system won't break</a:t>
             </a:r>
             <a:endParaRPr lang="en-US" sz="1200" dirty="0"/>
           </a:p>
@@ -21486,7 +21486,7 @@
                 <a:ea typeface="Calibri" pitchFamily="34" charset="-122"/>
                 <a:cs typeface="Calibri" pitchFamily="34" charset="-120"/>
               </a:rPr>
-              <a:t>Why good employers have not done this, and what we will give the first ten who will</a:t>
+              <a:t>Why good employers haven't done this, and what we will give the first ten who will</a:t>
             </a:r>
             <a:endParaRPr lang="en-US" sz="1200" dirty="0"/>
           </a:p>
@@ -21960,7 +21960,7 @@
                 <a:ea typeface="Cambria" pitchFamily="34" charset="-122"/>
                 <a:cs typeface="Cambria" pitchFamily="34" charset="-120"/>
               </a:rPr>
-              <a:t>Measured again in 2022 and 2025. It has not closed.</a:t>
+              <a:t>Measured again in 2022 and 2025. It hasn't closed.</a:t>
             </a:r>
             <a:endParaRPr lang="en-US" sz="1350" dirty="0"/>
           </a:p>

</xml_diff>

<commit_message>
Deck rebuilt with the 2025 evidence and the open offer
Co-Authored-By: Claude Fable 5.1 <noreply@anthropic.com>
</commit_message>
<xml_diff>
--- a/submission/Curb-Cut.pptx
+++ b/submission/Curb-Cut.pptx
@@ -4754,7 +4754,7 @@
                 <a:ea typeface="Calibri" pitchFamily="34" charset="-122"/>
                 <a:cs typeface="Calibri" pitchFamily="34" charset="-120"/>
               </a:rPr>
-              <a:t>The people this affects are more likely to be paid by the hour, to work part time, and to be in service, production and transport jobs. The programmes exist at 98% of large employers (2026 index); the telling has not moved.</a:t>
+              <a:t>The people this affects are more likely to be paid by the hour, to work part time, and to be in service, production and transport jobs. By 2026, 98% of participating employers report flexible or remote accommodations; the latest self-identification rate, 2025, did not rise.</a:t>
             </a:r>
             <a:endParaRPr lang="en-US" sz="1400" dirty="0"/>
           </a:p>
@@ -6021,7 +6021,7 @@
                 <a:ea typeface="Calibri" pitchFamily="34" charset="-122"/>
                 <a:cs typeface="Calibri" pitchFamily="34" charset="-120"/>
               </a:rPr>
-              <a:t>Contractors, temps, gig workers</a:t>
+              <a:t>Hourly, shift and minimum-wage workers</a:t>
             </a:r>
             <a:endParaRPr lang="en-US" sz="1350" dirty="0"/>
           </a:p>
@@ -6060,7 +6060,7 @@
                 <a:ea typeface="Calibri" pitchFamily="34" charset="-122"/>
                 <a:cs typeface="Calibri" pitchFamily="34" charset="-120"/>
               </a:rPr>
-              <a:t>no work login, no HR relationship, still expected to disclose</a:t>
+              <a:t>nearly twice as likely to be part time; no work email, no desk, no HR office on the floor</a:t>
             </a:r>
             <a:endParaRPr lang="en-US" sz="1200" dirty="0"/>
           </a:p>
@@ -6124,7 +6124,7 @@
                 <a:ea typeface="Calibri" pitchFamily="34" charset="-122"/>
                 <a:cs typeface="Calibri" pitchFamily="34" charset="-120"/>
               </a:rPr>
-              <a:t>People with invisible conditions</a:t>
+              <a:t>Contractors, temps, gig workers</a:t>
             </a:r>
             <a:endParaRPr lang="en-US" sz="1350" dirty="0"/>
           </a:p>
@@ -6163,7 +6163,7 @@
                 <a:ea typeface="Calibri" pitchFamily="34" charset="-122"/>
                 <a:cs typeface="Calibri" pitchFamily="34" charset="-120"/>
               </a:rPr>
-              <a:t>62% of disabled employees. Believed less, asked to prove more</a:t>
+              <a:t>no work login, no HR relationship, still expected to disclose</a:t>
             </a:r>
             <a:endParaRPr lang="en-US" sz="1200" dirty="0"/>
           </a:p>
@@ -6227,7 +6227,7 @@
                 <a:ea typeface="Calibri" pitchFamily="34" charset="-122"/>
                 <a:cs typeface="Calibri" pitchFamily="34" charset="-120"/>
               </a:rPr>
-              <a:t>Deaf and hard-of-hearing workers</a:t>
+              <a:t>People with invisible conditions</a:t>
             </a:r>
             <a:endParaRPr lang="en-US" sz="1350" dirty="0"/>
           </a:p>
@@ -6266,7 +6266,7 @@
                 <a:ea typeface="Calibri" pitchFamily="34" charset="-122"/>
                 <a:cs typeface="Calibri" pitchFamily="34" charset="-120"/>
               </a:rPr>
-              <a:t>almost every escalation path ends at "give us a call"</a:t>
+              <a:t>62% of disabled employees. Believed less, asked to prove more</a:t>
             </a:r>
             <a:endParaRPr lang="en-US" sz="1200" dirty="0"/>
           </a:p>
@@ -6330,7 +6330,7 @@
                 <a:ea typeface="Calibri" pitchFamily="34" charset="-122"/>
                 <a:cs typeface="Calibri" pitchFamily="34" charset="-120"/>
               </a:rPr>
-              <a:t>Anyone in their first weeks</a:t>
+              <a:t>Deaf and hard-of-hearing workers</a:t>
             </a:r>
             <a:endParaRPr lang="en-US" sz="1350" dirty="0"/>
           </a:p>
@@ -6369,6 +6369,109 @@
                 <a:ea typeface="Calibri" pitchFamily="34" charset="-122"/>
                 <a:cs typeface="Calibri" pitchFamily="34" charset="-120"/>
               </a:rPr>
+              <a:t>almost every escalation path ends at "give us a call"</a:t>
+            </a:r>
+            <a:endParaRPr lang="en-US" sz="1200" dirty="0"/>
+          </a:p>
+        </p:txBody>
+      </p:sp>
+      <p:sp>
+        <p:nvSpPr>
+          <p:cNvPr id="17" name="Shape 15"/>
+          <p:cNvSpPr/>
+          <p:nvPr/>
+        </p:nvSpPr>
+        <p:spPr>
+          <a:xfrm>
+            <a:off x="777240" y="4608576"/>
+            <a:ext cx="54864" cy="365760"/>
+          </a:xfrm>
+          <a:prstGeom prst="rect">
+            <a:avLst/>
+          </a:prstGeom>
+          <a:solidFill>
+            <a:srgbClr val="C9A227"/>
+          </a:solidFill>
+          <a:ln w="12700">
+            <a:solidFill>
+              <a:srgbClr val="C9A227"/>
+            </a:solidFill>
+            <a:prstDash val="solid"/>
+          </a:ln>
+        </p:spPr>
+      </p:sp>
+      <p:sp>
+        <p:nvSpPr>
+          <p:cNvPr id="18" name="Text 16"/>
+          <p:cNvSpPr txBox="1"/>
+          <p:nvPr/>
+        </p:nvSpPr>
+        <p:spPr>
+          <a:xfrm>
+            <a:off x="1051560" y="4517136"/>
+            <a:ext cx="3931920" cy="365760"/>
+          </a:xfrm>
+          <a:prstGeom prst="rect">
+            <a:avLst/>
+          </a:prstGeom>
+          <a:noFill/>
+          <a:ln/>
+        </p:spPr>
+        <p:txBody>
+          <a:bodyPr wrap="square" lIns="0" tIns="0" rIns="0" bIns="0" rtlCol="0" anchor="ctr"/>
+          <a:lstStyle/>
+          <a:p>
+            <a:pPr indent="0" marL="0">
+              <a:buNone/>
+            </a:pPr>
+            <a:r>
+              <a:rPr lang="en-US" sz="1350" b="1" dirty="0">
+                <a:solidFill>
+                  <a:srgbClr val="14171A"/>
+                </a:solidFill>
+                <a:latin typeface="Calibri" pitchFamily="34" charset="0"/>
+                <a:ea typeface="Calibri" pitchFamily="34" charset="-122"/>
+                <a:cs typeface="Calibri" pitchFamily="34" charset="-120"/>
+              </a:rPr>
+              <a:t>Anyone in their first weeks</a:t>
+            </a:r>
+            <a:endParaRPr lang="en-US" sz="1350" dirty="0"/>
+          </a:p>
+        </p:txBody>
+      </p:sp>
+      <p:sp>
+        <p:nvSpPr>
+          <p:cNvPr id="19" name="Text 17"/>
+          <p:cNvSpPr txBox="1"/>
+          <p:nvPr/>
+        </p:nvSpPr>
+        <p:spPr>
+          <a:xfrm>
+            <a:off x="5212080" y="4544568"/>
+            <a:ext cx="6217920" cy="365760"/>
+          </a:xfrm>
+          <a:prstGeom prst="rect">
+            <a:avLst/>
+          </a:prstGeom>
+          <a:noFill/>
+          <a:ln/>
+        </p:spPr>
+        <p:txBody>
+          <a:bodyPr wrap="square" lIns="0" tIns="0" rIns="0" bIns="0" rtlCol="0" anchor="ctr"/>
+          <a:lstStyle/>
+          <a:p>
+            <a:pPr indent="0" marL="0">
+              <a:buNone/>
+            </a:pPr>
+            <a:r>
+              <a:rPr lang="en-US" sz="1200" dirty="0">
+                <a:solidFill>
+                  <a:srgbClr val="42474C"/>
+                </a:solidFill>
+                <a:latin typeface="Calibri" pitchFamily="34" charset="0"/>
+                <a:ea typeface="Calibri" pitchFamily="34" charset="-122"/>
+                <a:cs typeface="Calibri" pitchFamily="34" charset="-120"/>
+              </a:rPr>
               <a:t>least social capital, highest perceived cost of asking</a:t>
             </a:r>
             <a:endParaRPr lang="en-US" sz="1200" dirty="0"/>
@@ -6377,7 +6480,7 @@
       </p:sp>
       <p:sp>
         <p:nvSpPr>
-          <p:cNvPr id="17" name="Text 15"/>
+          <p:cNvPr id="20" name="Text 18"/>
           <p:cNvSpPr txBox="1"/>
           <p:nvPr/>
         </p:nvSpPr>
@@ -6416,7 +6519,7 @@
       </p:sp>
       <p:sp>
         <p:nvSpPr>
-          <p:cNvPr id="18" name="Text 16"/>
+          <p:cNvPr id="21" name="Text 19"/>
           <p:cNvSpPr txBox="1"/>
           <p:nvPr/>
         </p:nvSpPr>
@@ -6455,7 +6558,7 @@
       </p:sp>
       <p:sp>
         <p:nvSpPr>
-          <p:cNvPr id="19" name="Text 17"/>
+          <p:cNvPr id="22" name="Text 20"/>
           <p:cNvSpPr txBox="1"/>
           <p:nvPr/>
         </p:nvSpPr>
@@ -6494,7 +6597,7 @@
       </p:sp>
       <p:sp>
         <p:nvSpPr>
-          <p:cNvPr id="20" name="Text 18"/>
+          <p:cNvPr id="23" name="Text 21"/>
           <p:cNvSpPr txBox="1"/>
           <p:nvPr/>
         </p:nvSpPr>
@@ -6533,7 +6636,7 @@
       </p:sp>
       <p:sp>
         <p:nvSpPr>
-          <p:cNvPr id="21" name="Text 19"/>
+          <p:cNvPr id="24" name="Text 22"/>
           <p:cNvSpPr txBox="1"/>
           <p:nvPr/>
         </p:nvSpPr>
@@ -6572,7 +6675,7 @@
       </p:sp>
       <p:sp>
         <p:nvSpPr>
-          <p:cNvPr id="22" name="Text 20"/>
+          <p:cNvPr id="25" name="Text 23"/>
           <p:cNvSpPr txBox="1"/>
           <p:nvPr/>
         </p:nvSpPr>
@@ -6611,7 +6714,7 @@
       </p:sp>
       <p:sp>
         <p:nvSpPr>
-          <p:cNvPr id="23" name="Text 21"/>
+          <p:cNvPr id="26" name="Text 24"/>
           <p:cNvSpPr txBox="1"/>
           <p:nvPr/>
         </p:nvSpPr>
@@ -6650,7 +6753,7 @@
       </p:sp>
       <p:sp>
         <p:nvSpPr>
-          <p:cNvPr id="24" name="Text 22"/>
+          <p:cNvPr id="27" name="Text 25"/>
           <p:cNvSpPr txBox="1"/>
           <p:nvPr/>
         </p:nvSpPr>
@@ -16646,7 +16749,7 @@
                 <a:ea typeface="Cambria" pitchFamily="34" charset="-122"/>
                 <a:cs typeface="Cambria" pitchFamily="34" charset="-120"/>
               </a:rPr>
-              <a:t>Every tool assumed disclosure first.</a:t>
+              <a:t>Every tool started from the diagnosis.</a:t>
             </a:r>
             <a:endParaRPr lang="en-US" sz="1300" dirty="0"/>
           </a:p>
@@ -16685,7 +16788,7 @@
                 <a:ea typeface="Calibri" pitchFamily="34" charset="-122"/>
                 <a:cs typeface="Calibri" pitchFamily="34" charset="-120"/>
               </a:rPr>
-              <a:t>HR systems start from a diagnosis field. Building one without it meant building something new, and nobody had.</a:t>
+              <a:t>HR systems have a field for it, and the newer accommodation platforms hold it on the employee's behalf. Building one with no field at all meant building something new.</a:t>
             </a:r>
             <a:endParaRPr lang="en-US" sz="1150" dirty="0"/>
           </a:p>
@@ -17470,7 +17573,7 @@
                 <a:ea typeface="Calibri" pitchFamily="34" charset="-122"/>
                 <a:cs typeface="Calibri" pitchFamily="34" charset="-120"/>
               </a:rPr>
-              <a:t>For roughly three in ten people at work, that calculation isn't occasional. It's a standing condition of the job, and the price of getting it wrong isn't an awkward moment. It's being seen as difficult, or fragile, or not worth staffing.</a:t>
+              <a:t>For about one in four adults, that calculation isn't occasional. It's a standing condition of the job, and the price of getting it wrong isn't an awkward moment. It's being seen as difficult, or fragile, or not worth staffing.</a:t>
             </a:r>
             <a:endParaRPr lang="en-US" sz="1600" dirty="0"/>
           </a:p>
@@ -18559,7 +18662,7 @@
                 <a:ea typeface="Calibri" pitchFamily="34" charset="-122"/>
                 <a:cs typeface="Calibri" pitchFamily="34" charset="-120"/>
               </a:rPr>
-              <a:t>98% of employers have the programmes</a:t>
+              <a:t>98% report flexible or remote accommodations</a:t>
             </a:r>
             <a:endParaRPr lang="en-US" sz="1200" dirty="0"/>
           </a:p>
@@ -18598,7 +18701,7 @@
                 <a:ea typeface="Calibri" pitchFamily="34" charset="-122"/>
                 <a:cs typeface="Calibri" pitchFamily="34" charset="-120"/>
               </a:rPr>
-              <a:t>Disability:IN 2026 index, 421 organisations; the disclosure gap persists</a:t>
+              <a:t>Disability:IN 2026 index, 421 organisations</a:t>
             </a:r>
             <a:endParaRPr lang="en-US" sz="1150" dirty="0"/>
           </a:p>

</xml_diff>

<commit_message>
Deck: slide 10 paragraph fits its box
Co-Authored-By: Claude Fable 5.1 <noreply@anthropic.com>
</commit_message>
<xml_diff>
--- a/submission/Curb-Cut.pptx
+++ b/submission/Curb-Cut.pptx
@@ -4729,24 +4729,24 @@
         </p:nvSpPr>
         <p:spPr>
           <a:xfrm>
-            <a:off x="777240" y="4343400"/>
-            <a:ext cx="10698480" cy="457200"/>
-          </a:xfrm>
-          <a:prstGeom prst="rect">
-            <a:avLst/>
-          </a:prstGeom>
-          <a:noFill/>
-          <a:ln/>
-        </p:spPr>
-        <p:txBody>
-          <a:bodyPr wrap="square" lIns="0" tIns="0" rIns="0" bIns="0" rtlCol="0" anchor="ctr"/>
-          <a:lstStyle/>
-          <a:p>
-            <a:pPr indent="0" marL="0">
-              <a:buNone/>
-            </a:pPr>
-            <a:r>
-              <a:rPr lang="en-US" sz="1400" dirty="0">
+            <a:off x="777240" y="4297680"/>
+            <a:ext cx="10698480" cy="548640"/>
+          </a:xfrm>
+          <a:prstGeom prst="rect">
+            <a:avLst/>
+          </a:prstGeom>
+          <a:noFill/>
+          <a:ln/>
+        </p:spPr>
+        <p:txBody>
+          <a:bodyPr wrap="square" lIns="0" tIns="0" rIns="0" bIns="0" rtlCol="0" anchor="ctr"/>
+          <a:lstStyle/>
+          <a:p>
+            <a:pPr indent="0" marL="0">
+              <a:buNone/>
+            </a:pPr>
+            <a:r>
+              <a:rPr lang="en-US" sz="1250" dirty="0">
                 <a:solidFill>
                   <a:srgbClr val="14171A"/>
                 </a:solidFill>
@@ -4756,7 +4756,7 @@
               </a:rPr>
               <a:t>The people this affects are more likely to be paid by the hour, to work part time, and to be in service, production and transport jobs. By 2026, 98% of participating employers report flexible or remote accommodations; the latest self-identification rate, 2025, did not rise.</a:t>
             </a:r>
-            <a:endParaRPr lang="en-US" sz="1400" dirty="0"/>
+            <a:endParaRPr lang="en-US" sz="1250" dirty="0"/>
           </a:p>
         </p:txBody>
       </p:sp>

</xml_diff>

<commit_message>
Deck: slide 12 rows clear the deployer label
Co-Authored-By: Claude Fable 5.1 <noreply@anthropic.com>
</commit_message>
<xml_diff>
--- a/submission/Curb-Cut.pptx
+++ b/submission/Curb-Cut.pptx
@@ -6074,7 +6074,7 @@
         </p:nvSpPr>
         <p:spPr>
           <a:xfrm>
-            <a:off x="777240" y="3017520"/>
+            <a:off x="777240" y="2926080"/>
             <a:ext cx="54864" cy="365760"/>
           </a:xfrm>
           <a:prstGeom prst="rect">
@@ -6099,7 +6099,7 @@
         </p:nvSpPr>
         <p:spPr>
           <a:xfrm>
-            <a:off x="1051560" y="2926080"/>
+            <a:off x="1051560" y="2834640"/>
             <a:ext cx="3931920" cy="365760"/>
           </a:xfrm>
           <a:prstGeom prst="rect">
@@ -6138,7 +6138,7 @@
         </p:nvSpPr>
         <p:spPr>
           <a:xfrm>
-            <a:off x="5212080" y="2953512"/>
+            <a:off x="5212080" y="2862072"/>
             <a:ext cx="6217920" cy="365760"/>
           </a:xfrm>
           <a:prstGeom prst="rect">
@@ -6177,7 +6177,7 @@
         </p:nvSpPr>
         <p:spPr>
           <a:xfrm>
-            <a:off x="777240" y="3547872"/>
+            <a:off x="777240" y="3364992"/>
             <a:ext cx="54864" cy="365760"/>
           </a:xfrm>
           <a:prstGeom prst="rect">
@@ -6202,7 +6202,7 @@
         </p:nvSpPr>
         <p:spPr>
           <a:xfrm>
-            <a:off x="1051560" y="3456432"/>
+            <a:off x="1051560" y="3273552"/>
             <a:ext cx="3931920" cy="365760"/>
           </a:xfrm>
           <a:prstGeom prst="rect">
@@ -6241,7 +6241,7 @@
         </p:nvSpPr>
         <p:spPr>
           <a:xfrm>
-            <a:off x="5212080" y="3483864"/>
+            <a:off x="5212080" y="3300984"/>
             <a:ext cx="6217920" cy="365760"/>
           </a:xfrm>
           <a:prstGeom prst="rect">
@@ -6280,7 +6280,7 @@
         </p:nvSpPr>
         <p:spPr>
           <a:xfrm>
-            <a:off x="777240" y="4078224"/>
+            <a:off x="777240" y="3803904"/>
             <a:ext cx="54864" cy="365760"/>
           </a:xfrm>
           <a:prstGeom prst="rect">
@@ -6305,7 +6305,7 @@
         </p:nvSpPr>
         <p:spPr>
           <a:xfrm>
-            <a:off x="1051560" y="3986784"/>
+            <a:off x="1051560" y="3712464"/>
             <a:ext cx="3931920" cy="365760"/>
           </a:xfrm>
           <a:prstGeom prst="rect">
@@ -6344,7 +6344,7 @@
         </p:nvSpPr>
         <p:spPr>
           <a:xfrm>
-            <a:off x="5212080" y="4014216"/>
+            <a:off x="5212080" y="3739896"/>
             <a:ext cx="6217920" cy="365760"/>
           </a:xfrm>
           <a:prstGeom prst="rect">
@@ -6383,7 +6383,7 @@
         </p:nvSpPr>
         <p:spPr>
           <a:xfrm>
-            <a:off x="777240" y="4608576"/>
+            <a:off x="777240" y="4242816"/>
             <a:ext cx="54864" cy="365760"/>
           </a:xfrm>
           <a:prstGeom prst="rect">
@@ -6408,7 +6408,7 @@
         </p:nvSpPr>
         <p:spPr>
           <a:xfrm>
-            <a:off x="1051560" y="4517136"/>
+            <a:off x="1051560" y="4151376"/>
             <a:ext cx="3931920" cy="365760"/>
           </a:xfrm>
           <a:prstGeom prst="rect">
@@ -6447,7 +6447,7 @@
         </p:nvSpPr>
         <p:spPr>
           <a:xfrm>
-            <a:off x="5212080" y="4544568"/>
+            <a:off x="5212080" y="4178808"/>
             <a:ext cx="6217920" cy="365760"/>
           </a:xfrm>
           <a:prstGeom prst="rect">

</xml_diff>

<commit_message>
Last four places with the old test count; deck line with the old accessibility count
Co-Authored-By: Claude Fable 5.1 <noreply@anthropic.com>
</commit_message>
<xml_diff>
--- a/submission/Curb-Cut.pptx
+++ b/submission/Curb-Cut.pptx
@@ -15553,7 +15553,7 @@
                 <a:ea typeface="Courier New" pitchFamily="34" charset="-122"/>
                 <a:cs typeface="Courier New" pitchFamily="34" charset="-120"/>
               </a:rPr>
-              <a:t>137 Apex   |   512 invariants   |   331 accessibility   |   131 Sa11y   |   28 contrast   |   16 reading level   |   all passing, every build</a:t>
+              <a:t>127 Apex   |   512 invariants   |   530 accessibility   |   131 Sa11y   |   28 contrast   |   16 reading level   |   all passing, every build</a:t>
             </a:r>
             <a:endParaRPr lang="en-US" sz="1200" dirty="0"/>
           </a:p>
@@ -19134,7 +19134,7 @@
                 <a:ea typeface="Courier New" pitchFamily="34" charset="-122"/>
                 <a:cs typeface="Courier New" pitchFamily="34" charset="-120"/>
               </a:rPr>
-              <a:t>137</a:t>
+              <a:t>127</a:t>
             </a:r>
             <a:endParaRPr lang="en-US" sz="1600" dirty="0"/>
           </a:p>

</xml_diff>